<commit_message>
Ajout des actions menées comme ambassadeur du festival Les 7 Jours du 7e Art
Co-Authored-By: Claude Opus 5.5 <noreply@anthropic.com>
Claude-Session: https://claude.ai/code/session_01Y44voEEgrqkDtN5faKYhcF
</commit_message>
<xml_diff>
--- a/GuineeImpact_Forum_Dakar_2026.pptx
+++ b/GuineeImpact_Forum_Dakar_2026.pptx
@@ -1127,7 +1127,7 @@
           <a:p>
             <a:r>
               <a:rPr lang="en-US" dirty="0"/>
-              <a:t>La culture au service de la paix (1 min). J'ai été ambassadeur de la 6e édition du festival Les 7 Jours du 7e Art, en décembre 2024. Chaque année à Conakry, ce festival fait vivre le cinéma guinéen et ouvre aux jeunes cinéastes des occasions de se former, de diffuser leurs films et de coproduire. Pourquoi un défenseur de la paix s'engage-t-il dans un festival de cinéma ? Parce qu'à Mamou, une pièce de théâtre en langue locale a touché plus de monde qu'un long discours. Le cinéma, c'est la même force, avec une portée plus grande. [Ajouter ce que vous avez fait comme ambassadeur.]</a:t>
+              <a:t>La culture au service de la paix (1 min 30). J'ai été ambassadeur du festival Les 7 Jours du 7e Art depuis sa 6e édition, en décembre 2024. Chaque année à Conakry, ce festival fait vivre le cinéma guinéen et ouvre aux jeunes cinéastes des occasions de se former, de diffuser leurs films et de coproduire. Pourquoi un défenseur de la paix s'engage-t-il dans un festival de cinéma ? Parce qu'à Mamou, une pièce de théâtre en langue locale a touché plus de monde qu'un long discours. Le cinéma, c'est la même force, avec une portée plus grande. Comme ambassadeur, avec nos équipes, nous avons noué des partenariats avec des médias internationaux comme TV5 Monde et Africa 24 et avec des personnalités africaines ; élaboré un plan d'action sur cinq ans ; fait former l'équipe de coordination par un spécialiste ; et hébergé l'équipe de gestion du festival dans les locaux de Guinée Impact, de la 6e édition à aujourd'hui. Notre rôle de société civile : donner aux jeunes créateurs les moyens de durer.</a:t>
             </a:r>
             <a:endParaRPr lang="en-US" dirty="0"/>
           </a:p>
@@ -5979,12 +5979,12 @@
         </p:nvSpPr>
         <p:spPr>
           <a:xfrm>
-            <a:off x="640080" y="1463040"/>
-            <a:ext cx="5303520" cy="3566160"/>
+            <a:off x="640080" y="1371600"/>
+            <a:ext cx="5303520" cy="4160520"/>
           </a:xfrm>
           <a:prstGeom prst="roundRect">
             <a:avLst>
-              <a:gd name="adj" fmla="val 2564"/>
+              <a:gd name="adj" fmla="val 2198"/>
             </a:avLst>
           </a:prstGeom>
           <a:solidFill>
@@ -6006,8 +6006,8 @@
         </p:nvSpPr>
         <p:spPr>
           <a:xfrm>
-            <a:off x="1005840" y="1737360"/>
-            <a:ext cx="731520" cy="731520"/>
+            <a:off x="1005840" y="1600200"/>
+            <a:ext cx="640080" cy="640080"/>
           </a:xfrm>
           <a:prstGeom prst="ellipse">
             <a:avLst/>
@@ -6039,8 +6039,8 @@
         </p:blipFill>
         <p:spPr>
           <a:xfrm>
-            <a:off x="1188720" y="1920240"/>
-            <a:ext cx="365760" cy="365760"/>
+            <a:off x="1165860" y="1760220"/>
+            <a:ext cx="320040" cy="320040"/>
           </a:xfrm>
           <a:prstGeom prst="rect">
             <a:avLst/>
@@ -6055,7 +6055,7 @@
         </p:nvSpPr>
         <p:spPr>
           <a:xfrm>
-            <a:off x="1005840" y="2651760"/>
+            <a:off x="1005840" y="2377440"/>
             <a:ext cx="4572000" cy="548640"/>
           </a:xfrm>
           <a:prstGeom prst="rect">
@@ -6094,8 +6094,8 @@
         </p:nvSpPr>
         <p:spPr>
           <a:xfrm>
-            <a:off x="1005840" y="3246120"/>
-            <a:ext cx="4572000" cy="1645920"/>
+            <a:off x="1005840" y="2971800"/>
+            <a:ext cx="4663440" cy="2423160"/>
           </a:xfrm>
           <a:prstGeom prst="rect">
             <a:avLst/>
@@ -6108,10 +6108,13 @@
           <a:lstStyle/>
           <a:p>
             <a:pPr indent="0" marL="0">
-              <a:buNone/>
-            </a:pPr>
-            <a:r>
-              <a:rPr lang="en-US" sz="1500" dirty="0">
+              <a:spcAft>
+                <a:spcPts val="300"/>
+              </a:spcAft>
+              <a:buNone/>
+            </a:pPr>
+            <a:r>
+              <a:rPr lang="en-US" sz="1400" dirty="0">
                 <a:solidFill>
                   <a:srgbClr val="2B2B2B"/>
                 </a:solidFill>
@@ -6121,7 +6124,7 @@
               </a:rPr>
               <a:t>Une pièce en langue locale sur les résolutions 1325 et 2250 et les MGF, devant plus de 100 personnes. Une histoire bien racontée touche plus de monde qu’un long discours.</a:t>
             </a:r>
-            <a:endParaRPr lang="en-US" sz="1500" dirty="0"/>
+            <a:endParaRPr lang="en-US" sz="1400" dirty="0"/>
           </a:p>
         </p:txBody>
       </p:sp>
@@ -6133,12 +6136,12 @@
         </p:nvSpPr>
         <p:spPr>
           <a:xfrm>
-            <a:off x="6217920" y="1463040"/>
-            <a:ext cx="5303520" cy="3566160"/>
+            <a:off x="6217920" y="1371600"/>
+            <a:ext cx="5303520" cy="4160520"/>
           </a:xfrm>
           <a:prstGeom prst="roundRect">
             <a:avLst>
-              <a:gd name="adj" fmla="val 2564"/>
+              <a:gd name="adj" fmla="val 2198"/>
             </a:avLst>
           </a:prstGeom>
           <a:solidFill>
@@ -6160,8 +6163,8 @@
         </p:nvSpPr>
         <p:spPr>
           <a:xfrm>
-            <a:off x="6583680" y="1737360"/>
-            <a:ext cx="731520" cy="731520"/>
+            <a:off x="6583680" y="1600200"/>
+            <a:ext cx="640080" cy="640080"/>
           </a:xfrm>
           <a:prstGeom prst="ellipse">
             <a:avLst/>
@@ -6193,8 +6196,8 @@
         </p:blipFill>
         <p:spPr>
           <a:xfrm>
-            <a:off x="6766560" y="1920240"/>
-            <a:ext cx="365760" cy="365760"/>
+            <a:off x="6743700" y="1760220"/>
+            <a:ext cx="320040" cy="320040"/>
           </a:xfrm>
           <a:prstGeom prst="rect">
             <a:avLst/>
@@ -6209,7 +6212,7 @@
         </p:nvSpPr>
         <p:spPr>
           <a:xfrm>
-            <a:off x="6583680" y="2651760"/>
+            <a:off x="6583680" y="2377440"/>
             <a:ext cx="4572000" cy="548640"/>
           </a:xfrm>
           <a:prstGeom prst="rect">
@@ -6248,8 +6251,8 @@
         </p:nvSpPr>
         <p:spPr>
           <a:xfrm>
-            <a:off x="6583680" y="3246120"/>
-            <a:ext cx="4572000" cy="1645920"/>
+            <a:off x="6583680" y="2971800"/>
+            <a:ext cx="4663440" cy="2423160"/>
           </a:xfrm>
           <a:prstGeom prst="rect">
             <a:avLst/>
@@ -6262,10 +6265,13 @@
           <a:lstStyle/>
           <a:p>
             <a:pPr indent="0" marL="0">
-              <a:buNone/>
-            </a:pPr>
-            <a:r>
-              <a:rPr lang="en-US" sz="1500" dirty="0">
+              <a:spcAft>
+                <a:spcPts val="400"/>
+              </a:spcAft>
+              <a:buNone/>
+            </a:pPr>
+            <a:r>
+              <a:rPr lang="en-US" sz="1400" b="1" dirty="0">
                 <a:solidFill>
                   <a:srgbClr val="2B2B2B"/>
                 </a:solidFill>
@@ -6273,9 +6279,93 @@
                 <a:ea typeface="Calibri" pitchFamily="34" charset="-122"/>
                 <a:cs typeface="Calibri" pitchFamily="34" charset="-120"/>
               </a:rPr>
-              <a:t>Ambassadeur de la 6ᵉ édition (décembre 2024). Chaque année à Conakry, le festival fait vivre le cinéma guinéen et ouvre des portes aux jeunes cinéastes : projections en plein air, débats, ateliers.</a:t>
-            </a:r>
-            <a:endParaRPr lang="en-US" sz="1500" dirty="0"/>
+              <a:t>Ambassadeur depuis la 6ᵉ édition (décembre 2024) :</a:t>
+            </a:r>
+            <a:endParaRPr lang="en-US" sz="1400" dirty="0"/>
+          </a:p>
+          <a:p>
+            <a:pPr marL="342900" indent="-342900">
+              <a:spcAft>
+                <a:spcPts val="300"/>
+              </a:spcAft>
+              <a:buSzPct val="100000"/>
+              <a:buChar char="•"/>
+            </a:pPr>
+            <a:r>
+              <a:rPr lang="en-US" sz="1400" dirty="0">
+                <a:solidFill>
+                  <a:srgbClr val="2B2B2B"/>
+                </a:solidFill>
+                <a:latin typeface="Calibri" pitchFamily="34" charset="0"/>
+                <a:ea typeface="Calibri" pitchFamily="34" charset="-122"/>
+                <a:cs typeface="Calibri" pitchFamily="34" charset="-120"/>
+              </a:rPr>
+              <a:t>Partenariats avec TV5 Monde, Africa 24 et des personnalités africaines</a:t>
+            </a:r>
+            <a:endParaRPr lang="en-US" sz="1400" dirty="0"/>
+          </a:p>
+          <a:p>
+            <a:pPr marL="342900" indent="-342900">
+              <a:spcAft>
+                <a:spcPts val="300"/>
+              </a:spcAft>
+              <a:buSzPct val="100000"/>
+              <a:buChar char="•"/>
+            </a:pPr>
+            <a:r>
+              <a:rPr lang="en-US" sz="1400" dirty="0">
+                <a:solidFill>
+                  <a:srgbClr val="2B2B2B"/>
+                </a:solidFill>
+                <a:latin typeface="Calibri" pitchFamily="34" charset="0"/>
+                <a:ea typeface="Calibri" pitchFamily="34" charset="-122"/>
+                <a:cs typeface="Calibri" pitchFamily="34" charset="-120"/>
+              </a:rPr>
+              <a:t>Plan d’action sur cinq ans</a:t>
+            </a:r>
+            <a:endParaRPr lang="en-US" sz="1400" dirty="0"/>
+          </a:p>
+          <a:p>
+            <a:pPr marL="342900" indent="-342900">
+              <a:spcAft>
+                <a:spcPts val="300"/>
+              </a:spcAft>
+              <a:buSzPct val="100000"/>
+              <a:buChar char="•"/>
+            </a:pPr>
+            <a:r>
+              <a:rPr lang="en-US" sz="1400" dirty="0">
+                <a:solidFill>
+                  <a:srgbClr val="2B2B2B"/>
+                </a:solidFill>
+                <a:latin typeface="Calibri" pitchFamily="34" charset="0"/>
+                <a:ea typeface="Calibri" pitchFamily="34" charset="-122"/>
+                <a:cs typeface="Calibri" pitchFamily="34" charset="-120"/>
+              </a:rPr>
+              <a:t>Équipe de coordination formée par un spécialiste</a:t>
+            </a:r>
+            <a:endParaRPr lang="en-US" sz="1400" dirty="0"/>
+          </a:p>
+          <a:p>
+            <a:pPr marL="342900" indent="-342900">
+              <a:spcAft>
+                <a:spcPts val="300"/>
+              </a:spcAft>
+              <a:buSzPct val="100000"/>
+              <a:buChar char="•"/>
+            </a:pPr>
+            <a:r>
+              <a:rPr lang="en-US" sz="1400" dirty="0">
+                <a:solidFill>
+                  <a:srgbClr val="2B2B2B"/>
+                </a:solidFill>
+                <a:latin typeface="Calibri" pitchFamily="34" charset="0"/>
+                <a:ea typeface="Calibri" pitchFamily="34" charset="-122"/>
+                <a:cs typeface="Calibri" pitchFamily="34" charset="-120"/>
+              </a:rPr>
+              <a:t>Équipe de gestion hébergée chez Guinée Impact</a:t>
+            </a:r>
+            <a:endParaRPr lang="en-US" sz="1400" dirty="0"/>
           </a:p>
         </p:txBody>
       </p:sp>
@@ -6287,7 +6377,7 @@
         </p:nvSpPr>
         <p:spPr>
           <a:xfrm>
-            <a:off x="640080" y="5349240"/>
+            <a:off x="640080" y="5760720"/>
             <a:ext cx="10881360" cy="731520"/>
           </a:xfrm>
           <a:prstGeom prst="rect">

</xml_diff>

<commit_message>
Discours raccourci à 10 minutes, notes des diapositives synchronisées
Co-Authored-By: Claude Opus 5.5 <noreply@anthropic.com>
Claude-Session: https://claude.ai/code/session_01Y44voEEgrqkDtN5faKYhcF
</commit_message>
<xml_diff>
--- a/GuineeImpact_Forum_Dakar_2026.pptx
+++ b/GuineeImpact_Forum_Dakar_2026.pptx
@@ -511,7 +511,7 @@
           <a:p>
             <a:r>
               <a:rPr lang="en-US" dirty="0"/>
-              <a:t>Ouverture (1 min). Mesdames et Messieurs, chères sœurs et chers frères activistes. Je m'appelle Mamadou Adama BARRY, Président de Guinée Impact, organisation membre du Groupe de Travail Femmes, Jeunes, Paix et Sécurité en Afrique de l'Ouest et au Sahel, en Guinée. À Somone, nous avons pris des engagements ensemble. Je suis venu vous rendre compte de ce que Guinée Impact en a fait. Rien de cela n'aurait été possible sans nos équipes, nos collaborateur·rices, notre Directeur Exécutif M. Racine Diallo, et surtout les femmes et les jeunes avec qui nous travaillons.</a:t>
+              <a:t>Ouverture (45 secondes). Mesdames et Messieurs, chères sœurs et chers frères activistes, Je m’appelle Mamadou Adama BARRY, Président de Guinée Impact , organisation membre du Groupe de Travail Femmes, Jeunes, Paix et Sécurité en Afrique de l’Ouest et au Sahel, en Guinée. À Somone, nous avons pris des engagements ensemble. Je viens vous rendre compte de ce que nous en avons fait. Et je le dis d’emblée : rien de tout cela n’aurait été possible sans nos équipes, notre Directeur Exécutif, M. Racine Diallo, et surtout les femmes et les jeunes avec qui nous travaillons sur le terrain.</a:t>
             </a:r>
             <a:endParaRPr lang="en-US" dirty="0"/>
           </a:p>
@@ -599,7 +599,7 @@
           <a:p>
             <a:r>
               <a:rPr lang="en-US" dirty="0"/>
-              <a:t>Conclusion (30 s). À Somone, nous avons dit que la politique est façonnée par celles et ceux qui s'engagent. Depuis, à Mamou, à Marrakech et sur les écrans de Conakry, nous avons appris que l'engagement finit toujours par être vu, et que l'art aide à le faire entendre. Nos voix, notre paix : continuons à les porter ensemble, jusqu'au dernier village. Je vous remercie.</a:t>
+              <a:t>Conclusion (30 secondes). À Somone, nous avons dit que la politique est façonnée par celles et ceux qui s’engagent. Depuis, à Mamou, à Marrakech et sur les écrans de Conakry, nous avons appris que l’engagement finit toujours par être vu. Nos voix, notre paix : continuons à les porter ensemble, jusqu’au dernier village. Je vous remercie.</a:t>
             </a:r>
             <a:endParaRPr lang="en-US" dirty="0"/>
           </a:p>
@@ -687,7 +687,7 @@
           <a:p>
             <a:r>
               <a:rPr lang="en-US" dirty="0"/>
-              <a:t>Guinée Impact en bref (30 s). Plateforme de la société civile guinéenne basée à Conakry. Mission : gouvernance responsable, participation citoyenne, paix, inclusion sociale, leadership et autonomisation des jeunes et des femmes. Membre du Groupe de Travail Femmes, Jeunes, Paix et Sécurité et partenaire du projet FIFEP, financé par le Fonds des Nations Unies pour la consolidation de la paix.</a:t>
+              <a:t>Guinée Impact en bref (30 secondes). Guinée Impact est une plateforme de la société civile guinéenne, basée à Conakry. Notre mission : promouvoir une gouvernance responsable, la participation citoyenne, la paix, le leadership et l’autonomisation des jeunes et des femmes. Nous sommes partenaire du projet Filles et Femmes Engagées pour la Construction de la Paix en Guinée (FIFEP), financé par le Fonds des Nations Unies pour la consolidation de la paix.</a:t>
             </a:r>
             <a:endParaRPr lang="en-US" dirty="0"/>
           </a:p>
@@ -775,7 +775,7 @@
           <a:p>
             <a:r>
               <a:rPr lang="en-US" dirty="0"/>
-              <a:t>Notre parcours en dates (1 min 30). Avec notre Groupe de Travail et nos partenaires : juillet 2024, validation des indicateurs de la plateforme numérique de suivi de la participation des filles et des femmes, et formation de 20 mouvements politiques et OSC à l'alerte précoce ; août 2024, stratégie nationale de plaidoyer construite à partir de 11 plans locaux (FIFEP) ; 2024, réunion annuelle du Groupe de Travail à Accra ; octobre 2024, partenariat renforcé avec CARE International ; décembre 2024, ambassadeur de la 6e édition du festival Les 7 Jours du 7e Art ; janvier 2025, Mamou ; juin 2025, Marrakech ; aujourd'hui, Dakar.</a:t>
+              <a:t>Notre parcours en dates (1 minute). Avec notre Groupe de Travail et nos partenaires : Juillet 2024 : nous validons les indicateurs d’une plateforme numérique de suivi de la participation des filles et des femmes à la paix, et nous formons 20 mouvements politiques et organisations de la société civile à l’alerte précoce. Août 2024 : une stratégie nationale de plaidoyer voit le jour, construite à partir des plans locaux de 11 zones. Fin 2024 : nous partageons notre expérience à Accra, avec le Groupe de Travail sous-régional, et nous renforçons notre partenariat avec CARE International. Puis viennent Mamou, le festival Les 7 Jours du 7ᵉ Art et Marrakech. Je vous les raconte.</a:t>
             </a:r>
             <a:endParaRPr lang="en-US" dirty="0"/>
           </a:p>
@@ -863,7 +863,7 @@
           <a:p>
             <a:r>
               <a:rPr lang="en-US" dirty="0"/>
-              <a:t>Mamou (2 min). Une stratégie ne change rien si elle reste dans un bureau. Du 16 au 20 janvier 2025, nos équipes l'ont portée jusqu'aux communautés : radio interactive de 2 heures en direct ; table ronde de 30 femmes leaders, jeunes et OSC sur les obstacles à la participation des femmes ; dialogue communautaire de 50 personnes avec les leaders religieux sur les résolutions 1325 et 2250 et les MGF ; soirée culturelle avec théâtre en langue locale devant plus de 100 personnes ; deux espaces de dialogue intergénérationnel. Plus de 180 personnes réunies.</a:t>
+              <a:t>Mamou : cinq jours, cinq façons de parler aux communautés (2 minutes). Une stratégie ne change rien si elle reste dans un bureau. Du 16 au 20 janvier 2025, à Mamou, nos équipes l’ont portée jusqu’aux communautés, avec cinq formats : La radio : une émission interactive de deux heures, en direct, avec des femmes leaders et de jeunes activistes. La table ronde : 30 femmes leaders, jeunes et membres d’organisations de la société civile ont analysé les obstacles à la participation des femmes et proposé des solutions. Le lieu de culte : un dialogue de 50 personnes, mené avec les leaders religieux et communautaires, sur les résolutions 1325 et 2250 et sur les mutilations génitales féminines. La scène : du théâtre en langue locale, devant plus de 100 personnes. Le cercle intergénérationnel : deux espaces de dialogue entre femmes leaders et jeunes. Au total, plus de 180 personnes réunies en cinq jours, sans compter les auditeur·rices de la radio.</a:t>
             </a:r>
             <a:endParaRPr lang="en-US" dirty="0"/>
           </a:p>
@@ -951,7 +951,7 @@
           <a:p>
             <a:r>
               <a:rPr lang="en-US" dirty="0"/>
-              <a:t>Une reconnaissance internationale (1 min 30, avec la diapositive suivante). Les 19 et 20 juin 2025, à Marrakech, premier Youth Empowerment Summit – YES Africa, co-organisé par la Fondation Jadara et l'Union Panafricaine de la Jeunesse : plus de 1 000 jeunes leaders, 118 ONG, 43 pays. J'y ai été distingué Champion de la jeunesse africaine sur le droit des jeunes et leur implication dans les instances de prise de décision. À Somone, nous avons demandé une participation significative des jeunes dans les instances de décision : ce combat est entendu à l'échelle du continent. Mais un titre ne suffit pas : ce qui compte, c'est que les jeunes, et en particulier les jeunes femmes, siègent réellement là où les décisions se prennent. Ce titre appartient à nos équipes, aux femmes leaders de Mamou, aux leaders religieux et aux jeunes.</a:t>
+              <a:t>Une reconnaissance internationale (1 minute 30). En juin 2025, à Marrakech, s’est tenu le premier Youth Empowerment Summit – YES Africa : plus de 1 000 jeunes leaders, 118 ONG, 43 pays africains. J’y ai été distingué « Champion de la jeunesse africaine sur le droit des jeunes et leur implication dans les instances de prise de décision » . À Somone, nous avons demandé que les jeunes participent vraiment aux décisions. Ce titre montre que ce combat est entendu à l’échelle du continent. Mais un titre ne suffit pas : ce qui compte, c’est que les jeunes, et en particulier les jeunes femmes, siègent réellement là où les décisions se prennent. Ce titre ne m’appartient pas. Il appartient à nos équipes, aux femmes leaders de Mamou, aux leaders religieux qui ont ouvert le dialogue, et aux jeunes qui se sont engagé·es. Et il dit à chacune et chacun d’entre vous : votre travail compte, et il peut être vu.</a:t>
             </a:r>
             <a:endParaRPr lang="en-US" dirty="0"/>
           </a:p>
@@ -1039,7 +1039,7 @@
           <a:p>
             <a:r>
               <a:rPr lang="en-US" dirty="0"/>
-              <a:t>J'y ai aussi pris la parole comme intervenant de la conférence sur la résilience climatique, l'agriculture et l'agroalimentaire pour la jeunesse africaine, aux côtés d'expert·es du Malawi, du Maroc et du Bénin, en tant que leader de l'agroécologie et de l'autonomisation des jeunes. Quand la terre s'épuise et que les récoltes manquent, les tensions montent, et ce sont souvent les femmes et les jeunes qui en paient le prix. La sécurité alimentaire fait partie de la paix.</a:t>
+              <a:t>Suite de la reconnaissance internationale. J’y suis aussi intervenu sur la résilience climatique, l’agriculture et la sécurité alimentaire, en tant que leader de l’agroécologie et de l’autonomisation des jeunes. Ce n’est pas loin de notre sujet : quand les récoltes manquent, les tensions montent, et ce sont souvent les femmes et les jeunes qui en paient le prix. La sécurité alimentaire fait partie de la paix.</a:t>
             </a:r>
             <a:endParaRPr lang="en-US" dirty="0"/>
           </a:p>
@@ -1127,7 +1127,7 @@
           <a:p>
             <a:r>
               <a:rPr lang="en-US" dirty="0"/>
-              <a:t>La culture au service de la paix (1 min 30). J'ai été ambassadeur du festival Les 7 Jours du 7e Art depuis sa 6e édition, en décembre 2024. Chaque année à Conakry, ce festival fait vivre le cinéma guinéen et ouvre aux jeunes cinéastes des occasions de se former, de diffuser leurs films et de coproduire. Pourquoi un défenseur de la paix s'engage-t-il dans un festival de cinéma ? Parce qu'à Mamou, une pièce de théâtre en langue locale a touché plus de monde qu'un long discours. Le cinéma, c'est la même force, avec une portée plus grande. Comme ambassadeur, avec nos équipes, nous avons noué des partenariats avec des médias internationaux comme TV5 Monde et Africa 24 et avec des personnalités africaines ; élaboré un plan d'action sur cinq ans ; fait former l'équipe de coordination par un spécialiste ; et hébergé l'équipe de gestion du festival dans les locaux de Guinée Impact, de la 6e édition à aujourd'hui. Notre rôle de société civile : donner aux jeunes créateurs les moyens de durer.</a:t>
+              <a:t>La culture au service de la paix : le cinéma (1 minute 15). Depuis la 6ᵉ édition, en décembre 2024, je suis ambassadeur du festival Les 7 Jours du 7ᵉ Art , qui fait vivre chaque année à Conakry le cinéma guinéen et ouvre des portes aux jeunes cinéastes. Pourquoi un défenseur de la paix s’engage-t-il dans un festival de cinéma ? Parce qu’à Mamou, une pièce de théâtre en langue locale a touché plus de monde qu’un long discours. Le cinéma a la même force, avec une portée plus grande. Avec nos équipes, nous avons noué des partenariats avec TV5 Monde , Africa 24 et des personnalités africaines ; élaboré un plan d’action sur cinq ans ; fait former l’équipe de coordination par un spécialiste ; et nous hébergeons l’équipe de gestion du festival dans nos locaux. Notre rôle de société civile, c’est aussi de donner aux jeunes créateur·rices les moyens de durer.</a:t>
             </a:r>
             <a:endParaRPr lang="en-US" dirty="0"/>
           </a:p>
@@ -1215,7 +1215,7 @@
           <a:p>
             <a:r>
               <a:rPr lang="en-US" dirty="0"/>
-              <a:t>Ce que nous avons appris (1 min) et ce qui nous freine (30 s). Les résistances se lèvent par le dialogue, avec les leaders religieux. La culture est un outil de plaidoyer. Les générations ont besoin l'une de l'autre. Nos défis : la mobilisation des participant·es, la logistique, la dépendance aux financements par projet, et la mesure du changement réel dans les attitudes et les comportements.</a:t>
+              <a:t>Ce que nous avons appris (45 secondes). Les résistances se lèvent par le dialogue. Sur les MGF, nous n’avons pas imposé : nous avons discuté, et quand les leaders religieux ont pris la parole, le message a été reçu autrement. La culture est un outil de plaidoyer. Une histoire bien racontée explique la résolution 1325 mieux qu’un long discours. Les générations ont besoin l’une de l’autre. Les femmes leaders apportent l’expérience ; les jeunes, l’énergie et de nouveaux outils. Ce qui nous freine (20 secondes). Nous restons lucides : mobiliser coûte cher, nos activités dépendent de financements par projet, et nous devons mieux mesurer le changement réel des attitudes.</a:t>
             </a:r>
             <a:endParaRPr lang="en-US" dirty="0"/>
           </a:p>
@@ -1303,7 +1303,7 @@
           <a:p>
             <a:r>
               <a:rPr lang="en-US" dirty="0"/>
-              <a:t>Nos propositions (1 min). 1. Reproduire le modèle cinq formats dans la campagne régionale décidée à Somone. 2. Associer les leaders religieux et communautaires aux campagnes sur les VBG et les MGF. 3. Construire ensemble des indicateurs communs du changement d'attitude, en s'appuyant sur ceux déjà validés en Guinée. 4. Demander aux partenaires, dont ONU Femmes, des financements pluriannuels. 5. Organiser des ciné-débats avec les festivals de la région. 6. Relier notre réseau aux réseaux d'autonomisation des jeunes comme YES Africa.</a:t>
+              <a:t>Nos propositions pour la région (1 minute). Reproduire le modèle « cinq formats » dans la campagne régionale contre les violences faites aux femmes et aux filles. Associer les leaders religieux et communautaires aux campagnes sur les VBG et les MGF. Construire des indicateurs communs pour mesurer le changement d’attitude. Obtenir des partenaires, dont ONU Femmes, des financements pluriannuels pour les organisations locales. Organiser des ciné-débats sur les résolutions 1325 et 2250 avec les festivals de la région. Relier notre réseau aux réseaux panafricains d’autonomisation des jeunes, comme YES Africa.</a:t>
             </a:r>
             <a:endParaRPr lang="en-US" dirty="0"/>
           </a:p>

</xml_diff>